<commit_message>
fix(sanitize_zip): preserve Greek letters and math operators in OMML equations
- Removed Greek-letter and math-operator replacements from _ZIP_ASCII_REPLACEMENTS.
- sanitize_zip now encodes remaining non-ASCII bytes as XML numeric character references, keeping Word OMML equations visually correct while files remain ASCII-clean.
- Regenerated all BPP submission outputs including inline figure/table manuscript version.
- Verified by bpp_mechanical_check.py: non_ascii empty, omml_equation_count 1, latex_markers empty.

Co-Authored-By: Tatsuki Onishi <bougtoir@gmail.com>
</commit_message>
<xml_diff>
--- a/medical_accident_its_analysis/manuscript/bpp_supplementary_figures.pptx
+++ b/medical_accident_its_analysis/manuscript/bpp_supplementary_figures.pptx
@@ -5371,7 +5371,7 @@
           <a:spcPct val="20000"/>
         </a:spcBef>
         <a:buFont typeface="Arial"/>
-        <a:buChar char="&gt;&gt;"/>
+        <a:buChar char="»"/>
         <a:defRPr sz="2000" kern="1200">
           <a:solidFill>
             <a:schemeClr val="tx1"/>
@@ -5881,7 +5881,7 @@
           <a:spcPct val="20000"/>
         </a:spcBef>
         <a:buFont typeface="Arial"/>
-        <a:buChar char="&gt;&gt;"/>
+        <a:buChar char="»"/>
         <a:defRPr sz="2000" kern="1200">
           <a:solidFill>
             <a:schemeClr val="tx1"/>

</xml_diff>